<commit_message>
Update Product Roadmap slide: clarify current MVP is 100% operational and ready now
</commit_message>
<xml_diff>
--- a/GCC_Intel_Product_Strategy_Deck.pptx
+++ b/GCC_Intel_Product_Strategy_Deck.pptx
@@ -3929,7 +3929,7 @@
               </a:defRPr>
             </a:pPr>
             <a:r>
-              <a:t>6-Month Strategic Horizon: From MVP to Enterprise Standard</a:t>
+              <a:t>Strategic Execution Horizon: From Live MVP to Enterprise Scale</a:t>
             </a:r>
           </a:p>
         </p:txBody>
@@ -4009,22 +4009,37 @@
               </a:defRPr>
             </a:pPr>
             <a:r>
-              <a:t>Phase 1: Foundation (Month 1)</a:t>
-            </a:r>
-          </a:p>
-          <a:p>
-            <a:pPr>
-              <a:spcBef>
-                <a:spcPts val="600"/>
-              </a:spcBef>
-              <a:defRPr sz="1100">
-                <a:solidFill>
-                  <a:srgbClr val="94A3B8"/>
-                </a:solidFill>
-              </a:defRPr>
-            </a:pPr>
-            <a:r>
-              <a:t>• STATUS: LIVE &amp; DEPLOYED.</a:t>
+              <a:t>Current MVP (Ready Now)</a:t>
+            </a:r>
+          </a:p>
+          <a:p>
+            <a:pPr>
+              <a:spcBef>
+                <a:spcPts val="600"/>
+              </a:spcBef>
+              <a:defRPr sz="1100">
+                <a:solidFill>
+                  <a:srgbClr val="94A3B8"/>
+                </a:solidFill>
+              </a:defRPr>
+            </a:pPr>
+            <a:r>
+              <a:t>• STATUS: LIVE &amp; 100% OPERATIONAL.</a:t>
+            </a:r>
+          </a:p>
+          <a:p>
+            <a:pPr>
+              <a:spcBef>
+                <a:spcPts val="600"/>
+              </a:spcBef>
+              <a:defRPr sz="1100">
+                <a:solidFill>
+                  <a:srgbClr val="94A3B8"/>
+                </a:solidFill>
+              </a:defRPr>
+            </a:pPr>
+            <a:r>
+              <a:t>• Built and launched rapidly as an evaluation-ready platform.</a:t>
             </a:r>
           </a:p>
           <a:p>
@@ -4054,7 +4069,7 @@
               </a:defRPr>
             </a:pPr>
             <a:r>
-              <a:t>• 5 Tier-1 Metros comparative matrix.</a:t>
+              <a:t>• 5 Tier-1 Metros comparative intelligence matrix.</a:t>
             </a:r>
           </a:p>
           <a:p>
@@ -4179,7 +4194,7 @@
               </a:defRPr>
             </a:pPr>
             <a:r>
-              <a:t>Phase 2: Tier-2 Hubs (Months 2-3)</a:t>
+              <a:t>Phase 1: Tier-2 Hubs (Months 1-2)</a:t>
             </a:r>
           </a:p>
           <a:p>
@@ -4319,7 +4334,7 @@
               </a:defRPr>
             </a:pPr>
             <a:r>
-              <a:t>Phase 3: Enterprise Platform (Months 4-6)</a:t>
+              <a:t>Phase 2: Enterprise Scale (Months 3-6)</a:t>
             </a:r>
           </a:p>
           <a:p>

</xml_diff>